<commit_message>
Remove Figure 2 footnote and tighten manuscript figure
Remote collaborators: Figure 4 review found that the crystallization mean MAE gain is concentrated in one source-shortfall pair; please consider this when revising the budget figure and text.
</commit_message>
<xml_diff>
--- a/output/pptx/chemworld-figure2-typography.pptx
+++ b/output/pptx/chemworld-figure2-typography.pptx
@@ -10,7 +10,7 @@
   <p:sldIdLst>
     <p:sldId id="256" r:id="rId3"/>
   </p:sldIdLst>
-  <p:sldSz cx="13716000" cy="10287000"/>
+  <p:sldSz cx="13716000" cy="9906000"/>
   <p:notesSz cx="6858000" cy="9144000"/>
   <p:defaultTextStyle>
     <a:lvl1pPr marL="0" algn="l" defTabSz="914400" rtl="0" eaLnBrk="1" latinLnBrk="0" hangingPunct="1">
@@ -654,7 +654,7 @@
       <p:grpSpPr/>
       <p:sp>
         <p:nvSpPr>
-          <p:cNvPr id="236" name="矩形 235"/>
+          <p:cNvPr id="234" name="矩形 233"/>
           <p:cNvSpPr>
             <a:spLocks noGrp="1"/>
           </p:cNvSpPr>
@@ -6890,7 +6890,7 @@
       </p:sp>
       <p:pic>
         <p:nvPicPr>
-          <p:cNvPr id="378" name="图片 377"/>
+          <p:cNvPr id="376" name="图片 375"/>
           <p:cNvPicPr>
             <a:picLocks noChangeAspect="1"/>
           </p:cNvPicPr>
@@ -6914,7 +6914,7 @@
       </p:pic>
       <p:pic>
         <p:nvPicPr>
-          <p:cNvPr id="379" name="图片 378"/>
+          <p:cNvPr id="377" name="图片 376"/>
           <p:cNvPicPr>
             <a:picLocks noChangeAspect="1"/>
           </p:cNvPicPr>
@@ -6938,7 +6938,7 @@
       </p:pic>
       <p:pic>
         <p:nvPicPr>
-          <p:cNvPr id="380" name="图片 379"/>
+          <p:cNvPr id="378" name="图片 377"/>
           <p:cNvPicPr>
             <a:picLocks noChangeAspect="1"/>
           </p:cNvPicPr>
@@ -6962,7 +6962,7 @@
       </p:pic>
       <p:pic>
         <p:nvPicPr>
-          <p:cNvPr id="381" name="图片 380"/>
+          <p:cNvPr id="379" name="图片 378"/>
           <p:cNvPicPr>
             <a:picLocks noChangeAspect="1"/>
           </p:cNvPicPr>
@@ -6986,7 +6986,7 @@
       </p:pic>
       <p:pic>
         <p:nvPicPr>
-          <p:cNvPr id="382" name="图片 381"/>
+          <p:cNvPr id="380" name="图片 379"/>
           <p:cNvPicPr>
             <a:picLocks noChangeAspect="1"/>
           </p:cNvPicPr>
@@ -7010,7 +7010,7 @@
       </p:pic>
       <p:pic>
         <p:nvPicPr>
-          <p:cNvPr id="383" name="图片 382"/>
+          <p:cNvPr id="381" name="图片 380"/>
           <p:cNvPicPr>
             <a:picLocks noChangeAspect="1"/>
           </p:cNvPicPr>
@@ -7034,7 +7034,7 @@
       </p:pic>
       <p:pic>
         <p:nvPicPr>
-          <p:cNvPr id="384" name="图片 383"/>
+          <p:cNvPr id="382" name="图片 381"/>
           <p:cNvPicPr>
             <a:picLocks noChangeAspect="1"/>
           </p:cNvPicPr>
@@ -7058,7 +7058,7 @@
       </p:pic>
       <p:pic>
         <p:nvPicPr>
-          <p:cNvPr id="385" name="图片 384"/>
+          <p:cNvPr id="383" name="图片 382"/>
           <p:cNvPicPr>
             <a:picLocks noChangeAspect="1"/>
           </p:cNvPicPr>
@@ -7082,7 +7082,7 @@
       </p:pic>
       <p:pic>
         <p:nvPicPr>
-          <p:cNvPr id="386" name="图片 385"/>
+          <p:cNvPr id="384" name="图片 383"/>
           <p:cNvPicPr>
             <a:picLocks noChangeAspect="1"/>
           </p:cNvPicPr>
@@ -7106,7 +7106,7 @@
       </p:pic>
       <p:pic>
         <p:nvPicPr>
-          <p:cNvPr id="387" name="图片 386"/>
+          <p:cNvPr id="385" name="图片 384"/>
           <p:cNvPicPr>
             <a:picLocks noChangeAspect="1"/>
           </p:cNvPicPr>
@@ -7998,7 +7998,7 @@
         <p:spPr>
           <a:xfrm>
             <a:off x="66675" y="6581775"/>
-            <a:ext cx="13582650" cy="3667125"/>
+            <a:ext cx="13582650" cy="3267075"/>
           </a:xfrm>
           <a:prstGeom prst="rect">
             <a:avLst/>
@@ -8236,7 +8236,7 @@
                 <a:ea typeface="Arial" panose="020B0604020202020204"/>
                 <a:cs typeface="Arial" panose="020B0604020202020204"/>
               </a:rPr>
-              <a:t>Agent question*</a:t>
+              <a:t>Agent question</a:t>
             </a:r>
             <a:endParaRPr sz="1425" b="1">
               <a:solidFill>
@@ -8603,7 +8603,7 @@
       </p:sp>
       <p:pic>
         <p:nvPicPr>
-          <p:cNvPr id="431" name="图片 430"/>
+          <p:cNvPr id="429" name="图片 428"/>
           <p:cNvPicPr>
             <a:picLocks noChangeAspect="1"/>
           </p:cNvPicPr>
@@ -9203,7 +9203,7 @@
       </p:sp>
       <p:pic>
         <p:nvPicPr>
-          <p:cNvPr id="445" name="图片 444"/>
+          <p:cNvPr id="443" name="图片 442"/>
           <p:cNvPicPr>
             <a:picLocks noChangeAspect="1"/>
           </p:cNvPicPr>
@@ -9803,7 +9803,7 @@
       </p:sp>
       <p:pic>
         <p:nvPicPr>
-          <p:cNvPr id="459" name="图片 458"/>
+          <p:cNvPr id="457" name="图片 456"/>
           <p:cNvPicPr>
             <a:picLocks noChangeAspect="1"/>
           </p:cNvPicPr>
@@ -10200,93 +10200,6 @@
             <a:endParaRPr sz="1350" b="1">
               <a:solidFill>
                 <a:srgbClr val="C85A3A"/>
-              </a:solidFill>
-              <a:latin typeface="Arial" panose="020B0604020202020204"/>
-              <a:ea typeface="Arial" panose="020B0604020202020204"/>
-              <a:cs typeface="Arial" panose="020B0604020202020204"/>
-            </a:endParaRPr>
-          </a:p>
-        </p:txBody>
-      </p:sp>
-      <p:sp>
-        <p:nvSpPr>
-          <p:cNvPr id="234" name="圆角矩形 233"/>
-          <p:cNvSpPr>
-            <a:spLocks noGrp="1"/>
-          </p:cNvSpPr>
-          <p:nvPr/>
-        </p:nvSpPr>
-        <p:spPr>
-          <a:xfrm>
-            <a:off x="238125" y="9820275"/>
-            <a:ext cx="13230225" cy="342900"/>
-          </a:xfrm>
-          <a:prstGeom prst="roundRect">
-            <a:avLst>
-              <a:gd name="adj" fmla="val 22222"/>
-            </a:avLst>
-          </a:prstGeom>
-          <a:solidFill>
-            <a:srgbClr val="F7FAFB"/>
-          </a:solidFill>
-          <a:ln w="9525">
-            <a:solidFill>
-              <a:srgbClr val="8295A2"/>
-            </a:solidFill>
-          </a:ln>
-        </p:spPr>
-      </p:sp>
-      <p:sp>
-        <p:nvSpPr>
-          <p:cNvPr id="235" name="矩形 234"/>
-          <p:cNvSpPr>
-            <a:spLocks noGrp="1"/>
-          </p:cNvSpPr>
-          <p:nvPr/>
-        </p:nvSpPr>
-        <p:spPr>
-          <a:xfrm>
-            <a:off x="428625" y="9867900"/>
-            <a:ext cx="12887325" cy="247650"/>
-          </a:xfrm>
-          <a:prstGeom prst="rect">
-            <a:avLst/>
-          </a:prstGeom>
-          <a:noFill/>
-          <a:ln w="0">
-            <a:noFill/>
-          </a:ln>
-        </p:spPr>
-        <p:txBody>
-          <a:bodyPr wrap="none" lIns="0" tIns="0" rIns="0" bIns="0" anchor="ctr">
-            <a:noAutofit/>
-          </a:bodyPr>
-          <a:lstStyle/>
-          <a:p>
-            <a:pPr algn="ctr">
-              <a:defRPr sz="1125" b="0">
-                <a:solidFill>
-                  <a:srgbClr val="27323A"/>
-                </a:solidFill>
-                <a:latin typeface="Arial" panose="020B0604020202020204"/>
-                <a:ea typeface="Arial" panose="020B0604020202020204"/>
-                <a:cs typeface="Arial" panose="020B0604020202020204"/>
-              </a:defRPr>
-            </a:pPr>
-            <a:r>
-              <a:rPr sz="1125" b="0">
-                <a:solidFill>
-                  <a:srgbClr val="27323A"/>
-                </a:solidFill>
-                <a:latin typeface="Arial" panose="020B0604020202020204"/>
-                <a:ea typeface="Arial" panose="020B0604020202020204"/>
-                <a:cs typeface="Arial" panose="020B0604020202020204"/>
-              </a:rPr>
-              <a:t>* Questions reconstructed from recorded actions, not contemporaneous model quotes. K1 was written after research; quench mechanism not isolated.</a:t>
-            </a:r>
-            <a:endParaRPr sz="1125" b="0">
-              <a:solidFill>
-                <a:srgbClr val="27323A"/>
               </a:solidFill>
               <a:latin typeface="Arial" panose="020B0604020202020204"/>
               <a:ea typeface="Arial" panose="020B0604020202020204"/>

</xml_diff>